<commit_message>
test: add real document fixtures and preview regressions
</commit_message>
<xml_diff>
--- a/Survoler.Tests/TestData/sample.pptx
+++ b/Survoler.Tests/TestData/sample.pptx
@@ -108,6 +108,11 @@
       </a:defRPr>
     </a:lvl9pPr>
   </p:defaultTextStyle>
+  <p:extLst>
+    <p:ext uri="{EFAFB233-063F-42B5-8137-9DF3F51BA10A}">
+      <p15:sldGuideLst xmlns:p15="http://schemas.microsoft.com/office/powerpoint/2012/main"/>
+    </p:ext>
+  </p:extLst>
 </p:presentation>
 </file>
 
@@ -1288,7 +1293,15 @@
     </dgm:pt>
     <dgm:pt modelId="{EE19D97F-5DA6-44A1-A459-27A1CD60B914}" type="pres">
       <dgm:prSet presAssocID="{A60FE6FE-471B-429F-A808-29225B208470}" presName="photoCircle" presStyleLbl="ltNode1NoLn" presStyleIdx="0" presStyleCnt="4"/>
-      <dgm:spPr/>
+      <dgm:spPr>
+        <a:blipFill>
+          <a:blip xmlns:r="http://schemas.openxmlformats.org/officeDocument/2006/relationships" r:embed="rId1"/>
+          <a:srcRect/>
+          <a:stretch>
+            <a:fillRect l="-35000" r="-35000"/>
+          </a:stretch>
+        </a:blipFill>
+      </dgm:spPr>
     </dgm:pt>
     <dgm:pt modelId="{59ED88E6-33CA-4468-B7F9-4586C2AF6202}" type="pres">
       <dgm:prSet presAssocID="{70BFA0F0-E95C-4DEC-8FC4-DDB29D78BA7F}" presName="sibTrans" presStyleCnt="0"/>
@@ -1321,7 +1334,15 @@
     </dgm:pt>
     <dgm:pt modelId="{6C2E8EDF-30E0-43D2-A1E5-3EC22C4CCD81}" type="pres">
       <dgm:prSet presAssocID="{64543702-2944-46D6-A1C0-17F1149962E0}" presName="photoCircle" presStyleLbl="ltNode1NoLn" presStyleIdx="1" presStyleCnt="4"/>
-      <dgm:spPr/>
+      <dgm:spPr>
+        <a:blipFill>
+          <a:blip xmlns:r="http://schemas.openxmlformats.org/officeDocument/2006/relationships" r:embed="rId2"/>
+          <a:srcRect/>
+          <a:stretch>
+            <a:fillRect l="-25000" r="-25000"/>
+          </a:stretch>
+        </a:blipFill>
+      </dgm:spPr>
     </dgm:pt>
     <dgm:pt modelId="{5DE5CCAD-FF59-495E-8C0C-FD19E15F8FA4}" type="pres">
       <dgm:prSet presAssocID="{E0899D51-9EC5-41E9-9760-19F9F331D861}" presName="sibTrans" presStyleCnt="0"/>
@@ -1354,7 +1375,15 @@
     </dgm:pt>
     <dgm:pt modelId="{2B678B5E-9C5A-4F3C-A4B5-A12DD3464D62}" type="pres">
       <dgm:prSet presAssocID="{CAA61C63-F29E-4AB8-8490-DC21A46AEDD1}" presName="photoCircle" presStyleLbl="ltNode1NoLn" presStyleIdx="2" presStyleCnt="4"/>
-      <dgm:spPr/>
+      <dgm:spPr>
+        <a:blipFill>
+          <a:blip xmlns:r="http://schemas.openxmlformats.org/officeDocument/2006/relationships" r:embed="rId3"/>
+          <a:srcRect/>
+          <a:stretch>
+            <a:fillRect t="-25000" b="-25000"/>
+          </a:stretch>
+        </a:blipFill>
+      </dgm:spPr>
     </dgm:pt>
     <dgm:pt modelId="{F7A14308-2391-4A68-8803-BD9AF1274E24}" type="pres">
       <dgm:prSet presAssocID="{28EAC434-C342-41A5-9DF1-8766E15C3101}" presName="sibTrans" presStyleCnt="0"/>
@@ -1387,7 +1416,15 @@
     </dgm:pt>
     <dgm:pt modelId="{D3293C81-DDA6-41DD-94D9-8642CE9ED5F9}" type="pres">
       <dgm:prSet presAssocID="{5AD9A9D0-ADB6-455E-9A0A-FD7AE4DC63E2}" presName="photoCircle" presStyleLbl="ltNode1NoLn" presStyleIdx="3" presStyleCnt="4"/>
-      <dgm:spPr/>
+      <dgm:spPr>
+        <a:blipFill>
+          <a:blip xmlns:r="http://schemas.openxmlformats.org/officeDocument/2006/relationships" r:embed="rId4"/>
+          <a:srcRect/>
+          <a:stretch>
+            <a:fillRect t="-25000" b="-25000"/>
+          </a:stretch>
+        </a:blipFill>
+      </dgm:spPr>
     </dgm:pt>
   </dgm:ptLst>
   <dgm:cxnLst>
@@ -1642,15 +1679,13 @@
         <a:prstGeom prst="ellipse">
           <a:avLst/>
         </a:prstGeom>
-        <a:solidFill>
-          <a:schemeClr val="accent1">
-            <a:tint val="75000"/>
-            <a:hueOff val="0"/>
-            <a:satOff val="0"/>
-            <a:lumOff val="0"/>
-            <a:alphaOff val="0"/>
-          </a:schemeClr>
-        </a:solidFill>
+        <a:blipFill>
+          <a:blip xmlns:r="http://schemas.openxmlformats.org/officeDocument/2006/relationships" r:embed="rId1"/>
+          <a:srcRect/>
+          <a:stretch>
+            <a:fillRect l="-35000" r="-35000"/>
+          </a:stretch>
+        </a:blipFill>
         <a:ln w="6350" cap="flat">
           <a:solidFill>
             <a:schemeClr val="lt1">
@@ -1880,15 +1915,13 @@
         <a:prstGeom prst="ellipse">
           <a:avLst/>
         </a:prstGeom>
-        <a:solidFill>
-          <a:schemeClr val="accent1">
-            <a:tint val="75000"/>
-            <a:hueOff val="0"/>
-            <a:satOff val="0"/>
-            <a:lumOff val="0"/>
-            <a:alphaOff val="0"/>
-          </a:schemeClr>
-        </a:solidFill>
+        <a:blipFill>
+          <a:blip xmlns:r="http://schemas.openxmlformats.org/officeDocument/2006/relationships" r:embed="rId2"/>
+          <a:srcRect/>
+          <a:stretch>
+            <a:fillRect l="-25000" r="-25000"/>
+          </a:stretch>
+        </a:blipFill>
         <a:ln w="6350" cap="flat">
           <a:solidFill>
             <a:schemeClr val="lt1">
@@ -2118,15 +2151,13 @@
         <a:prstGeom prst="ellipse">
           <a:avLst/>
         </a:prstGeom>
-        <a:solidFill>
-          <a:schemeClr val="accent1">
-            <a:tint val="75000"/>
-            <a:hueOff val="0"/>
-            <a:satOff val="0"/>
-            <a:lumOff val="0"/>
-            <a:alphaOff val="0"/>
-          </a:schemeClr>
-        </a:solidFill>
+        <a:blipFill>
+          <a:blip xmlns:r="http://schemas.openxmlformats.org/officeDocument/2006/relationships" r:embed="rId3"/>
+          <a:srcRect/>
+          <a:stretch>
+            <a:fillRect t="-25000" b="-25000"/>
+          </a:stretch>
+        </a:blipFill>
         <a:ln w="6350" cap="flat">
           <a:solidFill>
             <a:schemeClr val="lt1">
@@ -2356,15 +2387,13 @@
         <a:prstGeom prst="ellipse">
           <a:avLst/>
         </a:prstGeom>
-        <a:solidFill>
-          <a:schemeClr val="accent1">
-            <a:tint val="75000"/>
-            <a:hueOff val="0"/>
-            <a:satOff val="0"/>
-            <a:lumOff val="0"/>
-            <a:alphaOff val="0"/>
-          </a:schemeClr>
-        </a:solidFill>
+        <a:blipFill>
+          <a:blip xmlns:r="http://schemas.openxmlformats.org/officeDocument/2006/relationships" r:embed="rId4"/>
+          <a:srcRect/>
+          <a:stretch>
+            <a:fillRect t="-25000" b="-25000"/>
+          </a:stretch>
+        </a:blipFill>
         <a:ln w="6350" cap="flat">
           <a:solidFill>
             <a:schemeClr val="lt1">
@@ -5506,7 +5535,7 @@
           <p:nvPr>
             <p:extLst>
               <p:ext uri="{D42A27DB-BD31-4B8C-83A1-F6EECF244321}">
-                <p14:modId xmlns:p14="http://schemas.microsoft.com/office/powerpoint/2010/main" val="904273768"/>
+                <p14:modId xmlns:p14="http://schemas.microsoft.com/office/powerpoint/2010/main" val="3210689518"/>
               </p:ext>
             </p:extLst>
           </p:nvPr>

</xml_diff>